<commit_message>
doc: re-render showcase after the chart and inline-space fixes
</commit_message>
<xml_diff>
--- a/examples/showcase/decks/incident-postmortem/inc-2431-장애-회고.pptx
+++ b/examples/showcase/decks/incident-postmortem/inc-2431-장애-회고.pptx
@@ -7409,13 +7409,13 @@
       </p:sp>
       <p:sp>
         <p:nvSpPr>
-          <p:cNvPr id="4" name="text s7.1.0.0.0.0"/>
-          <p:cNvSpPr txBox="1"/>
-          <p:nvPr/>
-        </p:nvSpPr>
-        <p:spPr>
-          <a:xfrm>
-            <a:off x="609600" y="1381125"/>
+          <p:cNvPr id="4" name="text s7.1.0.0.0.0.1"/>
+          <p:cNvSpPr txBox="1"/>
+          <p:nvPr/>
+        </p:nvSpPr>
+        <p:spPr>
+          <a:xfrm>
+            <a:off x="609600" y="1699766"/>
             <a:ext cx="2194471" cy="239911"/>
           </a:xfrm>
           <a:prstGeom prst="rect">
@@ -7452,14 +7452,14 @@
       </p:sp>
       <p:sp>
         <p:nvSpPr>
-          <p:cNvPr id="5" name="shape s7.1.0.0.0.1"/>
+          <p:cNvPr id="5" name="shape s7.1.0.0.0.0.2"/>
           <p:cNvSpPr/>
           <p:nvPr/>
         </p:nvSpPr>
         <p:spPr>
           <a:xfrm>
-            <a:off x="938808" y="1678186"/>
-            <a:ext cx="1536055" cy="3547318"/>
+            <a:off x="938808" y="1996827"/>
+            <a:ext cx="1536055" cy="3228677"/>
           </a:xfrm>
           <a:prstGeom prst="rect">
             <a:avLst/>
@@ -7481,7 +7481,7 @@
       </p:sp>
       <p:sp>
         <p:nvSpPr>
-          <p:cNvPr id="6" name="shape s7.1.0.0.1"/>
+          <p:cNvPr id="6" name="shape s7.1.0.0.0.1"/>
           <p:cNvSpPr/>
           <p:nvPr/>
         </p:nvSpPr>
@@ -7510,14 +7510,14 @@
       </p:sp>
       <p:sp>
         <p:nvSpPr>
-          <p:cNvPr id="7" name="text s7.1.0.0.2"/>
-          <p:cNvSpPr txBox="1"/>
-          <p:nvPr/>
-        </p:nvSpPr>
-        <p:spPr>
-          <a:xfrm>
-            <a:off x="609600" y="5235029"/>
-            <a:ext cx="2194471" cy="239911"/>
+          <p:cNvPr id="7" name="text s7.1.0.0.1.0.1"/>
+          <p:cNvSpPr txBox="1"/>
+          <p:nvPr/>
+        </p:nvSpPr>
+        <p:spPr>
+          <a:xfrm>
+            <a:off x="2804071" y="2139851"/>
+            <a:ext cx="2194620" cy="239911"/>
           </a:xfrm>
           <a:prstGeom prst="rect">
             <a:avLst/>
@@ -7546,49 +7546,6 @@
                 <a:latin typeface="+mn-lt"/>
                 <a:ea typeface="+mn-ea"/>
               </a:rPr>
-              <a:t>5월</a:t>
-            </a:r>
-          </a:p>
-        </p:txBody>
-      </p:sp>
-      <p:sp>
-        <p:nvSpPr>
-          <p:cNvPr id="8" name="text s7.1.0.1.0.0"/>
-          <p:cNvSpPr txBox="1"/>
-          <p:nvPr/>
-        </p:nvSpPr>
-        <p:spPr>
-          <a:xfrm>
-            <a:off x="2804071" y="1864668"/>
-            <a:ext cx="2194620" cy="239911"/>
-          </a:xfrm>
-          <a:prstGeom prst="rect">
-            <a:avLst/>
-          </a:prstGeom>
-          <a:noFill/>
-          <a:ln>
-            <a:noFill/>
-          </a:ln>
-        </p:spPr>
-        <p:txBody>
-          <a:bodyPr wrap="square" lIns="0" tIns="0" rIns="0" bIns="0" anchor="t">
-            <a:normAutofit/>
-          </a:bodyPr>
-          <a:lstStyle/>
-          <a:p>
-            <a:pPr algn="ctr">
-              <a:lnSpc>
-                <a:spcPts val="1890"/>
-              </a:lnSpc>
-            </a:pPr>
-            <a:r>
-              <a:rPr sz="1350" b="0">
-                <a:solidFill>
-                  <a:schemeClr val="tx2"/>
-                </a:solidFill>
-                <a:latin typeface="+mn-lt"/>
-                <a:ea typeface="+mn-ea"/>
-              </a:rPr>
               <a:t>19분</a:t>
             </a:r>
           </a:p>
@@ -7596,14 +7553,14 @@
       </p:sp>
       <p:sp>
         <p:nvSpPr>
-          <p:cNvPr id="9" name="shape s7.1.0.1.0.1"/>
+          <p:cNvPr id="8" name="shape s7.1.0.0.1.0.2"/>
           <p:cNvSpPr/>
           <p:nvPr/>
         </p:nvSpPr>
         <p:spPr>
           <a:xfrm>
-            <a:off x="3133279" y="2161729"/>
-            <a:ext cx="1536204" cy="3063776"/>
+            <a:off x="3133279" y="2436912"/>
+            <a:ext cx="1536204" cy="2788593"/>
           </a:xfrm>
           <a:prstGeom prst="rect">
             <a:avLst/>
@@ -7625,7 +7582,7 @@
       </p:sp>
       <p:sp>
         <p:nvSpPr>
-          <p:cNvPr id="10" name="shape s7.1.0.1.1"/>
+          <p:cNvPr id="9" name="shape s7.1.0.0.1.1"/>
           <p:cNvSpPr/>
           <p:nvPr/>
         </p:nvSpPr>
@@ -7654,14 +7611,14 @@
       </p:sp>
       <p:sp>
         <p:nvSpPr>
-          <p:cNvPr id="11" name="text s7.1.0.1.2"/>
-          <p:cNvSpPr txBox="1"/>
-          <p:nvPr/>
-        </p:nvSpPr>
-        <p:spPr>
-          <a:xfrm>
-            <a:off x="2804071" y="5235029"/>
-            <a:ext cx="2194620" cy="239911"/>
+          <p:cNvPr id="10" name="text s7.1.0.0.2.0.1"/>
+          <p:cNvSpPr txBox="1"/>
+          <p:nvPr/>
+        </p:nvSpPr>
+        <p:spPr>
+          <a:xfrm>
+            <a:off x="4998690" y="2727275"/>
+            <a:ext cx="2194471" cy="239911"/>
           </a:xfrm>
           <a:prstGeom prst="rect">
             <a:avLst/>
@@ -7690,49 +7647,6 @@
                 <a:latin typeface="+mn-lt"/>
                 <a:ea typeface="+mn-ea"/>
               </a:rPr>
-              <a:t>6월</a:t>
-            </a:r>
-          </a:p>
-        </p:txBody>
-      </p:sp>
-      <p:sp>
-        <p:nvSpPr>
-          <p:cNvPr id="12" name="text s7.1.0.2.0.0"/>
-          <p:cNvSpPr txBox="1"/>
-          <p:nvPr/>
-        </p:nvSpPr>
-        <p:spPr>
-          <a:xfrm>
-            <a:off x="4998690" y="2509986"/>
-            <a:ext cx="2194471" cy="239911"/>
-          </a:xfrm>
-          <a:prstGeom prst="rect">
-            <a:avLst/>
-          </a:prstGeom>
-          <a:noFill/>
-          <a:ln>
-            <a:noFill/>
-          </a:ln>
-        </p:spPr>
-        <p:txBody>
-          <a:bodyPr wrap="square" lIns="0" tIns="0" rIns="0" bIns="0" anchor="t">
-            <a:normAutofit/>
-          </a:bodyPr>
-          <a:lstStyle/>
-          <a:p>
-            <a:pPr algn="ctr">
-              <a:lnSpc>
-                <a:spcPts val="1890"/>
-              </a:lnSpc>
-            </a:pPr>
-            <a:r>
-              <a:rPr sz="1350" b="0">
-                <a:solidFill>
-                  <a:schemeClr val="tx2"/>
-                </a:solidFill>
-                <a:latin typeface="+mn-lt"/>
-                <a:ea typeface="+mn-ea"/>
-              </a:rPr>
               <a:t>15분</a:t>
             </a:r>
           </a:p>
@@ -7740,14 +7654,14 @@
       </p:sp>
       <p:sp>
         <p:nvSpPr>
-          <p:cNvPr id="13" name="shape s7.1.0.2.0.1"/>
+          <p:cNvPr id="11" name="shape s7.1.0.0.2.0.2"/>
           <p:cNvSpPr/>
           <p:nvPr/>
         </p:nvSpPr>
         <p:spPr>
           <a:xfrm>
-            <a:off x="5327898" y="2807047"/>
-            <a:ext cx="1536055" cy="2418457"/>
+            <a:off x="5327898" y="3024336"/>
+            <a:ext cx="1536055" cy="2201168"/>
           </a:xfrm>
           <a:prstGeom prst="rect">
             <a:avLst/>
@@ -7769,7 +7683,7 @@
       </p:sp>
       <p:sp>
         <p:nvSpPr>
-          <p:cNvPr id="14" name="shape s7.1.0.2.1"/>
+          <p:cNvPr id="12" name="shape s7.1.0.0.2.1"/>
           <p:cNvSpPr/>
           <p:nvPr/>
         </p:nvSpPr>
@@ -7798,14 +7712,14 @@
       </p:sp>
       <p:sp>
         <p:nvSpPr>
-          <p:cNvPr id="15" name="text s7.1.0.2.2"/>
-          <p:cNvSpPr txBox="1"/>
-          <p:nvPr/>
-        </p:nvSpPr>
-        <p:spPr>
-          <a:xfrm>
-            <a:off x="4998690" y="5235029"/>
-            <a:ext cx="2194471" cy="239911"/>
+          <p:cNvPr id="13" name="text s7.1.0.0.3.0.1"/>
+          <p:cNvSpPr txBox="1"/>
+          <p:nvPr/>
+        </p:nvSpPr>
+        <p:spPr>
+          <a:xfrm>
+            <a:off x="7193161" y="3020616"/>
+            <a:ext cx="2194620" cy="239911"/>
           </a:xfrm>
           <a:prstGeom prst="rect">
             <a:avLst/>
@@ -7834,49 +7748,6 @@
                 <a:latin typeface="+mn-lt"/>
                 <a:ea typeface="+mn-ea"/>
               </a:rPr>
-              <a:t>7월</a:t>
-            </a:r>
-          </a:p>
-        </p:txBody>
-      </p:sp>
-      <p:sp>
-        <p:nvSpPr>
-          <p:cNvPr id="16" name="text s7.1.0.3.0.0"/>
-          <p:cNvSpPr txBox="1"/>
-          <p:nvPr/>
-        </p:nvSpPr>
-        <p:spPr>
-          <a:xfrm>
-            <a:off x="7193161" y="2832348"/>
-            <a:ext cx="2194620" cy="239911"/>
-          </a:xfrm>
-          <a:prstGeom prst="rect">
-            <a:avLst/>
-          </a:prstGeom>
-          <a:noFill/>
-          <a:ln>
-            <a:noFill/>
-          </a:ln>
-        </p:spPr>
-        <p:txBody>
-          <a:bodyPr wrap="square" lIns="0" tIns="0" rIns="0" bIns="0" anchor="t">
-            <a:normAutofit/>
-          </a:bodyPr>
-          <a:lstStyle/>
-          <a:p>
-            <a:pPr algn="ctr">
-              <a:lnSpc>
-                <a:spcPts val="1890"/>
-              </a:lnSpc>
-            </a:pPr>
-            <a:r>
-              <a:rPr sz="1350" b="0">
-                <a:solidFill>
-                  <a:schemeClr val="tx2"/>
-                </a:solidFill>
-                <a:latin typeface="+mn-lt"/>
-                <a:ea typeface="+mn-ea"/>
-              </a:rPr>
               <a:t>13분</a:t>
             </a:r>
           </a:p>
@@ -7884,14 +7755,14 @@
       </p:sp>
       <p:sp>
         <p:nvSpPr>
-          <p:cNvPr id="17" name="shape s7.1.0.3.0.1"/>
+          <p:cNvPr id="14" name="shape s7.1.0.0.3.0.2"/>
           <p:cNvSpPr/>
           <p:nvPr/>
         </p:nvSpPr>
         <p:spPr>
           <a:xfrm>
-            <a:off x="7522369" y="3129409"/>
-            <a:ext cx="1536204" cy="2096095"/>
+            <a:off x="7522369" y="3317677"/>
+            <a:ext cx="1536204" cy="1907828"/>
           </a:xfrm>
           <a:prstGeom prst="rect">
             <a:avLst/>
@@ -7913,7 +7784,7 @@
       </p:sp>
       <p:sp>
         <p:nvSpPr>
-          <p:cNvPr id="18" name="shape s7.1.0.3.1"/>
+          <p:cNvPr id="15" name="shape s7.1.0.0.3.1"/>
           <p:cNvSpPr/>
           <p:nvPr/>
         </p:nvSpPr>
@@ -7942,13 +7813,13 @@
       </p:sp>
       <p:sp>
         <p:nvSpPr>
-          <p:cNvPr id="19" name="text s7.1.0.3.2"/>
-          <p:cNvSpPr txBox="1"/>
-          <p:nvPr/>
-        </p:nvSpPr>
-        <p:spPr>
-          <a:xfrm>
-            <a:off x="7193161" y="5235029"/>
+          <p:cNvPr id="16" name="text s7.1.0.0.4.0.1"/>
+          <p:cNvSpPr txBox="1"/>
+          <p:nvPr/>
+        </p:nvSpPr>
+        <p:spPr>
+          <a:xfrm>
+            <a:off x="9387780" y="3167509"/>
             <a:ext cx="2194620" cy="239911"/>
           </a:xfrm>
           <a:prstGeom prst="rect">
@@ -7973,54 +7844,11 @@
             <a:r>
               <a:rPr sz="1350" b="0">
                 <a:solidFill>
-                  <a:schemeClr val="tx2"/>
+                  <a:schemeClr val="accent4"/>
                 </a:solidFill>
                 <a:latin typeface="+mn-lt"/>
                 <a:ea typeface="+mn-ea"/>
               </a:rPr>
-              <a:t>8월</a:t>
-            </a:r>
-          </a:p>
-        </p:txBody>
-      </p:sp>
-      <p:sp>
-        <p:nvSpPr>
-          <p:cNvPr id="20" name="text s7.1.0.4.0.0"/>
-          <p:cNvSpPr txBox="1"/>
-          <p:nvPr/>
-        </p:nvSpPr>
-        <p:spPr>
-          <a:xfrm>
-            <a:off x="9387780" y="2993678"/>
-            <a:ext cx="2194620" cy="239911"/>
-          </a:xfrm>
-          <a:prstGeom prst="rect">
-            <a:avLst/>
-          </a:prstGeom>
-          <a:noFill/>
-          <a:ln>
-            <a:noFill/>
-          </a:ln>
-        </p:spPr>
-        <p:txBody>
-          <a:bodyPr wrap="square" lIns="0" tIns="0" rIns="0" bIns="0" anchor="t">
-            <a:normAutofit/>
-          </a:bodyPr>
-          <a:lstStyle/>
-          <a:p>
-            <a:pPr algn="ctr">
-              <a:lnSpc>
-                <a:spcPts val="1890"/>
-              </a:lnSpc>
-            </a:pPr>
-            <a:r>
-              <a:rPr sz="1350" b="0">
-                <a:solidFill>
-                  <a:schemeClr val="accent4"/>
-                </a:solidFill>
-                <a:latin typeface="+mn-lt"/>
-                <a:ea typeface="+mn-ea"/>
-              </a:rPr>
               <a:t>12분</a:t>
             </a:r>
           </a:p>
@@ -8028,14 +7856,14 @@
       </p:sp>
       <p:sp>
         <p:nvSpPr>
-          <p:cNvPr id="21" name="shape s7.1.0.4.0.1"/>
+          <p:cNvPr id="17" name="shape s7.1.0.0.4.0.2"/>
           <p:cNvSpPr/>
           <p:nvPr/>
         </p:nvSpPr>
         <p:spPr>
           <a:xfrm>
-            <a:off x="9716988" y="3290739"/>
-            <a:ext cx="1536204" cy="1934766"/>
+            <a:off x="9716988" y="3464570"/>
+            <a:ext cx="1536204" cy="1760934"/>
           </a:xfrm>
           <a:prstGeom prst="rect">
             <a:avLst/>
@@ -8057,7 +7885,7 @@
       </p:sp>
       <p:sp>
         <p:nvSpPr>
-          <p:cNvPr id="22" name="shape s7.1.0.4.1"/>
+          <p:cNvPr id="18" name="shape s7.1.0.0.4.1"/>
           <p:cNvSpPr/>
           <p:nvPr/>
         </p:nvSpPr>
@@ -8086,7 +7914,179 @@
       </p:sp>
       <p:sp>
         <p:nvSpPr>
-          <p:cNvPr id="23" name="text s7.1.0.4.2"/>
+          <p:cNvPr id="19" name="text s7.1.0.1.0"/>
+          <p:cNvSpPr txBox="1"/>
+          <p:nvPr/>
+        </p:nvSpPr>
+        <p:spPr>
+          <a:xfrm>
+            <a:off x="609600" y="5235029"/>
+            <a:ext cx="2194471" cy="239911"/>
+          </a:xfrm>
+          <a:prstGeom prst="rect">
+            <a:avLst/>
+          </a:prstGeom>
+          <a:noFill/>
+          <a:ln>
+            <a:noFill/>
+          </a:ln>
+        </p:spPr>
+        <p:txBody>
+          <a:bodyPr wrap="square" lIns="0" tIns="0" rIns="0" bIns="0" anchor="t">
+            <a:normAutofit/>
+          </a:bodyPr>
+          <a:lstStyle/>
+          <a:p>
+            <a:pPr algn="ctr">
+              <a:lnSpc>
+                <a:spcPts val="1890"/>
+              </a:lnSpc>
+            </a:pPr>
+            <a:r>
+              <a:rPr sz="1350" b="0">
+                <a:solidFill>
+                  <a:schemeClr val="tx2"/>
+                </a:solidFill>
+                <a:latin typeface="+mn-lt"/>
+                <a:ea typeface="+mn-ea"/>
+              </a:rPr>
+              <a:t>5월</a:t>
+            </a:r>
+          </a:p>
+        </p:txBody>
+      </p:sp>
+      <p:sp>
+        <p:nvSpPr>
+          <p:cNvPr id="20" name="text s7.1.0.1.1"/>
+          <p:cNvSpPr txBox="1"/>
+          <p:nvPr/>
+        </p:nvSpPr>
+        <p:spPr>
+          <a:xfrm>
+            <a:off x="2804071" y="5235029"/>
+            <a:ext cx="2194620" cy="239911"/>
+          </a:xfrm>
+          <a:prstGeom prst="rect">
+            <a:avLst/>
+          </a:prstGeom>
+          <a:noFill/>
+          <a:ln>
+            <a:noFill/>
+          </a:ln>
+        </p:spPr>
+        <p:txBody>
+          <a:bodyPr wrap="square" lIns="0" tIns="0" rIns="0" bIns="0" anchor="t">
+            <a:normAutofit/>
+          </a:bodyPr>
+          <a:lstStyle/>
+          <a:p>
+            <a:pPr algn="ctr">
+              <a:lnSpc>
+                <a:spcPts val="1890"/>
+              </a:lnSpc>
+            </a:pPr>
+            <a:r>
+              <a:rPr sz="1350" b="0">
+                <a:solidFill>
+                  <a:schemeClr val="tx2"/>
+                </a:solidFill>
+                <a:latin typeface="+mn-lt"/>
+                <a:ea typeface="+mn-ea"/>
+              </a:rPr>
+              <a:t>6월</a:t>
+            </a:r>
+          </a:p>
+        </p:txBody>
+      </p:sp>
+      <p:sp>
+        <p:nvSpPr>
+          <p:cNvPr id="21" name="text s7.1.0.1.2"/>
+          <p:cNvSpPr txBox="1"/>
+          <p:nvPr/>
+        </p:nvSpPr>
+        <p:spPr>
+          <a:xfrm>
+            <a:off x="4998690" y="5235029"/>
+            <a:ext cx="2194471" cy="239911"/>
+          </a:xfrm>
+          <a:prstGeom prst="rect">
+            <a:avLst/>
+          </a:prstGeom>
+          <a:noFill/>
+          <a:ln>
+            <a:noFill/>
+          </a:ln>
+        </p:spPr>
+        <p:txBody>
+          <a:bodyPr wrap="square" lIns="0" tIns="0" rIns="0" bIns="0" anchor="t">
+            <a:normAutofit/>
+          </a:bodyPr>
+          <a:lstStyle/>
+          <a:p>
+            <a:pPr algn="ctr">
+              <a:lnSpc>
+                <a:spcPts val="1890"/>
+              </a:lnSpc>
+            </a:pPr>
+            <a:r>
+              <a:rPr sz="1350" b="0">
+                <a:solidFill>
+                  <a:schemeClr val="tx2"/>
+                </a:solidFill>
+                <a:latin typeface="+mn-lt"/>
+                <a:ea typeface="+mn-ea"/>
+              </a:rPr>
+              <a:t>7월</a:t>
+            </a:r>
+          </a:p>
+        </p:txBody>
+      </p:sp>
+      <p:sp>
+        <p:nvSpPr>
+          <p:cNvPr id="22" name="text s7.1.0.1.3"/>
+          <p:cNvSpPr txBox="1"/>
+          <p:nvPr/>
+        </p:nvSpPr>
+        <p:spPr>
+          <a:xfrm>
+            <a:off x="7193161" y="5235029"/>
+            <a:ext cx="2194620" cy="239911"/>
+          </a:xfrm>
+          <a:prstGeom prst="rect">
+            <a:avLst/>
+          </a:prstGeom>
+          <a:noFill/>
+          <a:ln>
+            <a:noFill/>
+          </a:ln>
+        </p:spPr>
+        <p:txBody>
+          <a:bodyPr wrap="square" lIns="0" tIns="0" rIns="0" bIns="0" anchor="t">
+            <a:normAutofit/>
+          </a:bodyPr>
+          <a:lstStyle/>
+          <a:p>
+            <a:pPr algn="ctr">
+              <a:lnSpc>
+                <a:spcPts val="1890"/>
+              </a:lnSpc>
+            </a:pPr>
+            <a:r>
+              <a:rPr sz="1350" b="0">
+                <a:solidFill>
+                  <a:schemeClr val="tx2"/>
+                </a:solidFill>
+                <a:latin typeface="+mn-lt"/>
+                <a:ea typeface="+mn-ea"/>
+              </a:rPr>
+              <a:t>8월</a:t>
+            </a:r>
+          </a:p>
+        </p:txBody>
+      </p:sp>
+      <p:sp>
+        <p:nvSpPr>
+          <p:cNvPr id="23" name="text s7.1.0.1.4"/>
           <p:cNvSpPr txBox="1"/>
           <p:nvPr/>
         </p:nvSpPr>

</xml_diff>